<commit_message>
Document executable scripts and publish regenerated outputs
</commit_message>
<xml_diff>
--- a/Faculty_Performance_Criteria_PNGs.pptx
+++ b/Faculty_Performance_Criteria_PNGs.pptx
@@ -3108,8 +3108,8 @@
         </p:blipFill>
         <p:spPr>
           <a:xfrm>
-            <a:off x="2710809" y="228600"/>
-            <a:ext cx="6770076" cy="6400800"/>
+            <a:off x="2762097" y="228600"/>
+            <a:ext cx="6667500" cy="6400800"/>
           </a:xfrm>
           <a:prstGeom prst="rect">
             <a:avLst/>

</xml_diff>